<commit_message>
Fix campaign slides, date formats, active count, cover spacing - 259 tests
</commit_message>
<xml_diff>
--- a/templates/dark.pptx
+++ b/templates/dark.pptx
@@ -3406,7 +3406,7 @@
         </p:nvSpPr>
         <p:spPr>
           <a:xfrm>
-            <a:off x="506630" y="5161635"/>
+            <a:off x="506630" y="5061635"/>
             <a:ext cx="1745519" cy="331071"/>
           </a:xfrm>
           <a:prstGeom prst="roundRect">
@@ -3493,7 +3493,7 @@
         </p:nvSpPr>
         <p:spPr>
           <a:xfrm>
-            <a:off x="506630" y="5633973"/>
+            <a:off x="506630" y="5533973"/>
             <a:ext cx="2831325" cy="276999"/>
           </a:xfrm>
           <a:prstGeom prst="rect">
@@ -3559,7 +3559,7 @@
         </p:nvSpPr>
         <p:spPr>
           <a:xfrm>
-            <a:off x="506630" y="5934011"/>
+            <a:off x="506630" y="5836972"/>
             <a:ext cx="3276600" cy="276900"/>
           </a:xfrm>
           <a:prstGeom prst="rect">
@@ -3625,7 +3625,7 @@
         </p:nvSpPr>
         <p:spPr>
           <a:xfrm>
-            <a:off x="502920" y="6236208"/>
+            <a:off x="502920" y="6139872"/>
             <a:ext cx="6400800" cy="274320"/>
           </a:xfrm>
           <a:prstGeom prst="rect">
@@ -3678,7 +3678,7 @@
         </p:nvSpPr>
         <p:spPr>
           <a:xfrm>
-            <a:off x="502920" y="6537960"/>
+            <a:off x="502920" y="6440192"/>
             <a:ext cx="6400800" cy="246888"/>
           </a:xfrm>
           <a:prstGeom prst="rect">

</xml_diff>

<commit_message>
Fix long account name wrapping - auto shrink font - 358 tests
</commit_message>
<xml_diff>
--- a/templates/dark.pptx
+++ b/templates/dark.pptx
@@ -3494,7 +3494,7 @@
         <p:spPr>
           <a:xfrm>
             <a:off x="506630" y="5533973"/>
-            <a:ext cx="2831325" cy="276999"/>
+            <a:ext cx="5300000" cy="400000"/>
           </a:xfrm>
           <a:prstGeom prst="rect">
             <a:avLst/>
@@ -3505,7 +3505,7 @@
           </a:ln>
         </p:spPr>
         <p:txBody>
-          <a:bodyPr anchorCtr="0" anchor="t" bIns="45700" lIns="0" spcFirstLastPara="1" rIns="0" wrap="square" tIns="45700">
+          <a:bodyPr anchorCtr="0" anchor="t" bIns="45700" lIns="0" spcFirstLastPara="1" rIns="0" wrap="none" tIns="45700">
             <a:spAutoFit/>
           </a:bodyPr>
           <a:lstStyle/>
@@ -3528,7 +3528,7 @@
               <a:buNone/>
             </a:pPr>
             <a:r>
-              <a:rPr b="0" i="0" lang="en-US" sz="1200" u="none" cap="none" strike="noStrike">
+              <a:rPr b="0" i="0" lang="en-US" sz="2800" u="none" cap="none" strike="noStrike">
                 <a:solidFill>
                   <a:schemeClr val="lt1"/>
                 </a:solidFill>
@@ -3559,7 +3559,7 @@
         </p:nvSpPr>
         <p:spPr>
           <a:xfrm>
-            <a:off x="506630" y="5836972"/>
+            <a:off x="506630" y="5966972"/>
             <a:ext cx="3276600" cy="276900"/>
           </a:xfrm>
           <a:prstGeom prst="rect">
@@ -3625,7 +3625,7 @@
         </p:nvSpPr>
         <p:spPr>
           <a:xfrm>
-            <a:off x="502920" y="6139872"/>
+            <a:off x="502920" y="6269872"/>
             <a:ext cx="6400800" cy="274320"/>
           </a:xfrm>
           <a:prstGeom prst="rect">
@@ -3678,7 +3678,7 @@
         </p:nvSpPr>
         <p:spPr>
           <a:xfrm>
-            <a:off x="502920" y="6440192"/>
+            <a:off x="502920" y="6570192"/>
             <a:ext cx="6400800" cy="246888"/>
           </a:xfrm>
           <a:prstGeom prst="rect">
@@ -7063,7 +7063,7 @@
           </a:ln>
         </p:spPr>
         <p:txBody>
-          <a:bodyPr anchorCtr="0" anchor="t" bIns="45700" lIns="91425" spcFirstLastPara="1" rIns="91425" wrap="square" tIns="45700">
+          <a:bodyPr anchorCtr="0" anchor="t" bIns="45700" lIns="91425" spcFirstLastPara="1" rIns="91425" wrap="none" tIns="45700">
             <a:spAutoFit/>
           </a:bodyPr>
           <a:lstStyle/>

</xml_diff>

<commit_message>
Improve cover slide - rounded logo corners and rebalance layout - 396 tests
</commit_message>
<xml_diff>
--- a/templates/dark.pptx
+++ b/templates/dark.pptx
@@ -3625,8 +3625,8 @@
         </p:nvSpPr>
         <p:spPr>
           <a:xfrm>
-            <a:off x="502920" y="6269872"/>
-            <a:ext cx="6400800" cy="274320"/>
+            <a:off x="5892000" y="6119872"/>
+            <a:ext cx="6000000" cy="274320"/>
           </a:xfrm>
           <a:prstGeom prst="rect">
             <a:avLst/>
@@ -3642,7 +3642,7 @@
           </a:bodyPr>
           <a:lstStyle/>
           <a:p>
-            <a:pPr indent="0" lvl="0" marL="0" marR="0" rtl="0" algn="l">
+            <a:pPr indent="0" lvl="0" marL="0" marR="0" rtl="0" algn="r">
               <a:lnSpc>
                 <a:spcPct val="100000"/>
               </a:lnSpc>
@@ -3678,8 +3678,8 @@
         </p:nvSpPr>
         <p:spPr>
           <a:xfrm>
-            <a:off x="502920" y="6570192"/>
-            <a:ext cx="6400800" cy="246888"/>
+            <a:off x="5892000" y="6420192"/>
+            <a:ext cx="6000000" cy="246888"/>
           </a:xfrm>
           <a:prstGeom prst="rect">
             <a:avLst/>
@@ -3695,7 +3695,7 @@
           </a:bodyPr>
           <a:lstStyle/>
           <a:p>
-            <a:pPr indent="0" lvl="0" marL="0" marR="0" rtl="0" algn="l">
+            <a:pPr indent="0" lvl="0" marL="0" marR="0" rtl="0" algn="r">
               <a:lnSpc>
                 <a:spcPct val="100000"/>
               </a:lnSpc>

</xml_diff>

<commit_message>
Fix inactive status, missing campaign slides, zero spend ad sets, font sizes - 490 tests
</commit_message>
<xml_diff>
--- a/templates/dark.pptx
+++ b/templates/dark.pptx
@@ -4050,7 +4050,7 @@
                   <a:buNone/>
                 </a:pPr>
                 <a:r>
-                  <a:rPr b="0" i="0" lang="en-US" sz="1050" u="none" cap="none" strike="noStrike">
+                  <a:rPr b="0" i="0" lang="en-US" sz="1150" u="none" cap="none" strike="noStrike">
                     <a:solidFill>
                       <a:schemeClr val="lt1"/>
                     </a:solidFill>
@@ -4116,7 +4116,7 @@
                   <a:buNone/>
                 </a:pPr>
                 <a:r>
-                  <a:rPr b="1" i="0" lang="en-US" sz="2000" u="none" cap="none" strike="noStrike">
+                  <a:rPr b="1" i="0" lang="en-US" sz="2100" u="none" cap="none" strike="noStrike">
                     <a:solidFill>
                       <a:schemeClr val="lt1"/>
                     </a:solidFill>
@@ -4443,7 +4443,7 @@
                   <a:buNone/>
                 </a:pPr>
                 <a:r>
-                  <a:rPr b="0" i="0" lang="en-US" sz="1050" u="none" cap="none" strike="noStrike">
+                  <a:rPr b="0" i="0" lang="en-US" sz="1150" u="none" cap="none" strike="noStrike">
                     <a:solidFill>
                       <a:schemeClr val="lt1"/>
                     </a:solidFill>
@@ -4509,7 +4509,7 @@
                   <a:buNone/>
                 </a:pPr>
                 <a:r>
-                  <a:rPr b="1" i="0" lang="en-US" sz="2000" u="none" cap="none" strike="noStrike">
+                  <a:rPr b="1" i="0" lang="en-US" sz="2100" u="none" cap="none" strike="noStrike">
                     <a:solidFill>
                       <a:schemeClr val="lt1"/>
                     </a:solidFill>
@@ -4836,7 +4836,7 @@
                   <a:buNone/>
                 </a:pPr>
                 <a:r>
-                  <a:rPr b="0" i="0" lang="en-US" sz="1050" u="none" cap="none" strike="noStrike">
+                  <a:rPr b="0" i="0" lang="en-US" sz="1150" u="none" cap="none" strike="noStrike">
                     <a:solidFill>
                       <a:schemeClr val="lt1"/>
                     </a:solidFill>
@@ -4902,7 +4902,7 @@
                   <a:buNone/>
                 </a:pPr>
                 <a:r>
-                  <a:rPr b="1" i="0" lang="en-US" sz="2000" u="none" cap="none" strike="noStrike">
+                  <a:rPr b="1" i="0" lang="en-US" sz="2100" u="none" cap="none" strike="noStrike">
                     <a:solidFill>
                       <a:schemeClr val="lt1"/>
                     </a:solidFill>
@@ -5229,7 +5229,7 @@
                   <a:buNone/>
                 </a:pPr>
                 <a:r>
-                  <a:rPr b="0" i="0" lang="en-US" sz="1050" u="none" cap="none" strike="noStrike">
+                  <a:rPr b="0" i="0" lang="en-US" sz="1150" u="none" cap="none" strike="noStrike">
                     <a:solidFill>
                       <a:schemeClr val="lt1"/>
                     </a:solidFill>
@@ -5295,7 +5295,7 @@
                   <a:buNone/>
                 </a:pPr>
                 <a:r>
-                  <a:rPr b="1" i="0" lang="en-US" sz="2000" u="none" cap="none" strike="noStrike">
+                  <a:rPr b="1" i="0" lang="en-US" sz="2100" u="none" cap="none" strike="noStrike">
                     <a:solidFill>
                       <a:schemeClr val="lt1"/>
                     </a:solidFill>
@@ -5608,7 +5608,7 @@
                 <a:buNone/>
               </a:pPr>
               <a:r>
-                <a:rPr b="0" i="0" lang="en-US" sz="1050" u="none" cap="none" strike="noStrike">
+                <a:rPr b="0" i="0" lang="en-US" sz="1150" u="none" cap="none" strike="noStrike">
                   <a:solidFill>
                     <a:schemeClr val="lt1"/>
                   </a:solidFill>
@@ -5674,7 +5674,7 @@
                 <a:buNone/>
               </a:pPr>
               <a:r>
-                <a:rPr b="1" i="0" lang="en-US" sz="2000" u="none" cap="none" strike="noStrike">
+                <a:rPr b="1" i="0" lang="en-US" sz="2100" u="none" cap="none" strike="noStrike">
                   <a:solidFill>
                     <a:schemeClr val="lt1"/>
                   </a:solidFill>
@@ -5986,7 +5986,7 @@
                 <a:buNone/>
               </a:pPr>
               <a:r>
-                <a:rPr b="0" i="0" lang="en-US" sz="1050" u="none" cap="none" strike="noStrike">
+                <a:rPr b="0" i="0" lang="en-US" sz="1150" u="none" cap="none" strike="noStrike">
                   <a:solidFill>
                     <a:schemeClr val="lt1"/>
                   </a:solidFill>
@@ -6052,7 +6052,7 @@
                 <a:buNone/>
               </a:pPr>
               <a:r>
-                <a:rPr b="1" i="0" lang="en-US" sz="2000" u="none" cap="none" strike="noStrike">
+                <a:rPr b="1" i="0" lang="en-US" sz="2100" u="none" cap="none" strike="noStrike">
                   <a:solidFill>
                     <a:schemeClr val="lt1"/>
                   </a:solidFill>
@@ -6364,7 +6364,7 @@
                 <a:buNone/>
               </a:pPr>
               <a:r>
-                <a:rPr b="0" i="0" lang="en-US" sz="1050" u="none" cap="none" strike="noStrike">
+                <a:rPr b="0" i="0" lang="en-US" sz="1150" u="none" cap="none" strike="noStrike">
                   <a:solidFill>
                     <a:schemeClr val="lt1"/>
                   </a:solidFill>
@@ -6430,7 +6430,7 @@
                 <a:buNone/>
               </a:pPr>
               <a:r>
-                <a:rPr b="1" i="0" lang="en-US" sz="2000" u="none" cap="none" strike="noStrike">
+                <a:rPr b="1" i="0" lang="en-US" sz="2100" u="none" cap="none" strike="noStrike">
                   <a:solidFill>
                     <a:schemeClr val="lt1"/>
                   </a:solidFill>

</xml_diff>

<commit_message>
Add 8th metric slot, auto-catch unknown columns, lightweight metric review, multi-slide support
</commit_message>
<xml_diff>
--- a/templates/dark.pptx
+++ b/templates/dark.pptx
@@ -6440,6 +6440,384 @@
                   <a:sym typeface="Poppins"/>
                 </a:rPr>
                 <a:t>{{METRIC_CPC}}</a:t>
+              </a:r>
+              <a:endParaRPr b="0" i="0" sz="1400" u="none" cap="none" strike="noStrike">
+                <a:solidFill>
+                  <a:srgbClr val="000000"/>
+                </a:solidFill>
+                <a:latin typeface="Arial"/>
+                <a:ea typeface="Arial"/>
+                <a:cs typeface="Arial"/>
+                <a:sym typeface="Arial"/>
+              </a:endParaRPr>
+            </a:p>
+          </p:txBody>
+        </p:sp>
+      </p:grpSp>
+      <p:sp>
+        <p:nvSpPr>
+          <p:cNvPr id="103" name="Google Shape;79;p5"/>
+          <p:cNvSpPr/>
+          <p:nvPr/>
+        </p:nvSpPr>
+        <p:spPr>
+          <a:xfrm>
+            <a:off x="3593639" y="5145377"/>
+            <a:ext cx="2907300" cy="1029900"/>
+          </a:xfrm>
+          <a:prstGeom prst="roundRect">
+            <a:avLst>
+              <a:gd fmla="val 12280" name="adj"/>
+            </a:avLst>
+          </a:prstGeom>
+          <a:solidFill>
+            <a:schemeClr val="accent5"/>
+          </a:solidFill>
+          <a:ln>
+            <a:noFill/>
+          </a:ln>
+          <a:effectLst>
+            <a:outerShdw blurRad="190500" sx="99000" rotWithShape="0" algn="t" dir="5400000" dist="63500" sy="99000">
+              <a:srgbClr val="000000">
+                <a:alpha val="20000"/>
+              </a:srgbClr>
+            </a:outerShdw>
+          </a:effectLst>
+        </p:spPr>
+        <p:txBody>
+          <a:bodyPr anchorCtr="0" anchor="ctr" bIns="45700" lIns="91425" spcFirstLastPara="1" rIns="91425" wrap="square" tIns="45700">
+            <a:noAutofit/>
+          </a:bodyPr>
+          <a:lstStyle/>
+          <a:p>
+            <a:pPr indent="0" lvl="0" marL="0" marR="0" rtl="0" algn="ctr">
+              <a:lnSpc>
+                <a:spcPct val="100000"/>
+              </a:lnSpc>
+              <a:spcBef>
+                <a:spcPts val="0"/>
+              </a:spcBef>
+              <a:spcAft>
+                <a:spcPts val="0"/>
+              </a:spcAft>
+              <a:buClr>
+                <a:srgbClr val="000000"/>
+              </a:buClr>
+              <a:buSzPts val="1600"/>
+              <a:buFont typeface="Arial"/>
+              <a:buNone/>
+            </a:pPr>
+            <a:r>
+              <a:t/>
+            </a:r>
+            <a:endParaRPr b="0" i="0" sz="1600" u="none" cap="none" strike="noStrike">
+              <a:solidFill>
+                <a:schemeClr val="lt1"/>
+              </a:solidFill>
+              <a:latin typeface="Calibri"/>
+              <a:ea typeface="Calibri"/>
+              <a:cs typeface="Calibri"/>
+              <a:sym typeface="Calibri"/>
+            </a:endParaRPr>
+          </a:p>
+        </p:txBody>
+      </p:sp>
+      <p:grpSp>
+        <p:nvGrpSpPr>
+          <p:cNvPr id="104" name="Google Shape;80;p5"/>
+          <p:cNvGrpSpPr/>
+          <p:nvPr/>
+        </p:nvGrpSpPr>
+        <p:grpSpPr>
+          <a:xfrm>
+            <a:off x="3714017" y="5302505"/>
+            <a:ext cx="717528" cy="717528"/>
+            <a:chOff x="3105456" y="1218956"/>
+            <a:chExt cx="1118516" cy="1118516"/>
+          </a:xfrm>
+        </p:grpSpPr>
+        <p:sp>
+          <p:nvSpPr>
+            <p:cNvPr id="105" name="Google Shape;81;p5"/>
+            <p:cNvSpPr/>
+            <p:nvPr/>
+          </p:nvSpPr>
+          <p:spPr>
+            <a:xfrm>
+              <a:off x="3105456" y="1218956"/>
+              <a:ext cx="1118516" cy="1118516"/>
+            </a:xfrm>
+            <a:custGeom>
+              <a:rect b="b" l="l" r="r" t="t"/>
+              <a:pathLst>
+                <a:path extrusionOk="0" h="2924226" w="2924226">
+                  <a:moveTo>
+                    <a:pt x="2924227" y="1462113"/>
+                  </a:moveTo>
+                  <a:cubicBezTo>
+                    <a:pt x="2924227" y="2269616"/>
+                    <a:pt x="2269616" y="2924227"/>
+                    <a:pt x="1462113" y="2924227"/>
+                  </a:cubicBezTo>
+                  <a:cubicBezTo>
+                    <a:pt x="654609" y="2924227"/>
+                    <a:pt x="-1" y="2269616"/>
+                    <a:pt x="-1" y="1462113"/>
+                  </a:cubicBezTo>
+                  <a:cubicBezTo>
+                    <a:pt x="-1" y="654610"/>
+                    <a:pt x="654609" y="0"/>
+                    <a:pt x="1462113" y="0"/>
+                  </a:cubicBezTo>
+                  <a:cubicBezTo>
+                    <a:pt x="2269616" y="0"/>
+                    <a:pt x="2924227" y="654610"/>
+                    <a:pt x="2924227" y="1462113"/>
+                  </a:cubicBezTo>
+                  <a:close/>
+                </a:path>
+              </a:pathLst>
+            </a:custGeom>
+            <a:gradFill>
+              <a:gsLst>
+                <a:gs pos="0">
+                  <a:schemeClr val="accent2"/>
+                </a:gs>
+                <a:gs pos="5000">
+                  <a:schemeClr val="accent2"/>
+                </a:gs>
+                <a:gs pos="34000">
+                  <a:schemeClr val="accent1"/>
+                </a:gs>
+                <a:gs pos="64000">
+                  <a:schemeClr val="accent3"/>
+                </a:gs>
+                <a:gs pos="90000">
+                  <a:schemeClr val="accent4"/>
+                </a:gs>
+                <a:gs pos="100000">
+                  <a:schemeClr val="accent4"/>
+                </a:gs>
+              </a:gsLst>
+              <a:lin ang="2700006" scaled="0"/>
+            </a:gradFill>
+            <a:ln>
+              <a:noFill/>
+            </a:ln>
+            <a:effectLst>
+              <a:outerShdw blurRad="190500" sx="99000" rotWithShape="0" algn="t" dir="5400000" dist="63500" sy="99000">
+                <a:srgbClr val="000000">
+                  <a:alpha val="20000"/>
+                </a:srgbClr>
+              </a:outerShdw>
+            </a:effectLst>
+          </p:spPr>
+          <p:txBody>
+            <a:bodyPr anchorCtr="0" anchor="ctr" bIns="45700" lIns="91425" spcFirstLastPara="1" rIns="91425" wrap="square" tIns="45700">
+              <a:noAutofit/>
+            </a:bodyPr>
+            <a:lstStyle/>
+            <a:p>
+              <a:pPr indent="0" lvl="0" marL="0" marR="0" rtl="0" algn="l">
+                <a:lnSpc>
+                  <a:spcPct val="100000"/>
+                </a:lnSpc>
+                <a:spcBef>
+                  <a:spcPts val="0"/>
+                </a:spcBef>
+                <a:spcAft>
+                  <a:spcPts val="0"/>
+                </a:spcAft>
+                <a:buClr>
+                  <a:srgbClr val="000000"/>
+                </a:buClr>
+                <a:buSzPts val="1300"/>
+                <a:buFont typeface="Arial"/>
+                <a:buNone/>
+              </a:pPr>
+              <a:r>
+                <a:t/>
+              </a:r>
+              <a:endParaRPr b="0" i="0" sz="1300" u="none" cap="none" strike="noStrike">
+                <a:solidFill>
+                  <a:schemeClr val="accent1"/>
+                </a:solidFill>
+                <a:latin typeface="Calibri"/>
+                <a:ea typeface="Calibri"/>
+                <a:cs typeface="Calibri"/>
+                <a:sym typeface="Calibri"/>
+              </a:endParaRPr>
+            </a:p>
+          </p:txBody>
+        </p:sp>
+        <p:pic>
+          <p:nvPicPr>
+            <p:cNvPr id="106" name="Google Shape;82;p5"/>
+            <p:cNvPicPr preferRelativeResize="0"/>
+            <p:nvPr/>
+          </p:nvPicPr>
+          <p:blipFill rotWithShape="1">
+            <a:blip r:embed="rId9">
+              <a:alphaModFix/>
+            </a:blip>
+            <a:srcRect b="0" l="0" r="0" t="0"/>
+            <a:stretch/>
+          </p:blipFill>
+          <p:spPr>
+            <a:xfrm>
+              <a:off x="3393457" y="1506957"/>
+              <a:ext cx="540001" cy="540001"/>
+            </a:xfrm>
+            <a:prstGeom prst="rect">
+              <a:avLst/>
+            </a:prstGeom>
+            <a:noFill/>
+            <a:ln>
+              <a:noFill/>
+            </a:ln>
+            <a:effectLst>
+              <a:outerShdw blurRad="177800" rotWithShape="0" algn="tl" dir="2700000" dist="114300">
+                <a:srgbClr val="000000">
+                  <a:alpha val="40000"/>
+                </a:srgbClr>
+              </a:outerShdw>
+            </a:effectLst>
+          </p:spPr>
+        </p:pic>
+      </p:grpSp>
+      <p:grpSp>
+        <p:nvGrpSpPr>
+          <p:cNvPr id="107" name="Google Shape;83;p5"/>
+          <p:cNvGrpSpPr/>
+          <p:nvPr/>
+        </p:nvGrpSpPr>
+        <p:grpSpPr>
+          <a:xfrm>
+            <a:off x="4655379" y="5329696"/>
+            <a:ext cx="1834048" cy="683137"/>
+            <a:chOff x="1112490" y="1363887"/>
+            <a:chExt cx="1485300" cy="553237"/>
+          </a:xfrm>
+        </p:grpSpPr>
+        <p:sp>
+          <p:nvSpPr>
+            <p:cNvPr id="108" name="Google Shape;84;p5"/>
+            <p:cNvSpPr txBox="1"/>
+            <p:nvPr/>
+          </p:nvSpPr>
+          <p:spPr>
+            <a:xfrm>
+              <a:off x="1112490" y="1363887"/>
+              <a:ext cx="1485300" cy="205500"/>
+            </a:xfrm>
+            <a:prstGeom prst="rect">
+              <a:avLst/>
+            </a:prstGeom>
+            <a:noFill/>
+            <a:ln>
+              <a:noFill/>
+            </a:ln>
+          </p:spPr>
+          <p:txBody>
+            <a:bodyPr anchorCtr="0" anchor="t" bIns="45700" lIns="0" spcFirstLastPara="1" rIns="91425" wrap="square" tIns="45700">
+              <a:spAutoFit/>
+            </a:bodyPr>
+            <a:lstStyle/>
+            <a:p>
+              <a:pPr indent="0" lvl="0" marL="0" marR="0" rtl="0" algn="l">
+                <a:lnSpc>
+                  <a:spcPct val="100000"/>
+                </a:lnSpc>
+                <a:spcBef>
+                  <a:spcPts val="0"/>
+                </a:spcBef>
+                <a:spcAft>
+                  <a:spcPts val="0"/>
+                </a:spcAft>
+                <a:buClr>
+                  <a:srgbClr val="000000"/>
+                </a:buClr>
+                <a:buSzPts val="1050"/>
+                <a:buFont typeface="Arial"/>
+                <a:buNone/>
+              </a:pPr>
+              <a:r>
+                <a:rPr b="0" i="0" lang="en-US" sz="1150" u="none" cap="none" strike="noStrike">
+                  <a:solidFill>
+                    <a:schemeClr val="lt1"/>
+                  </a:solidFill>
+                  <a:latin typeface="Poppins Medium"/>
+                  <a:ea typeface="Poppins Medium"/>
+                  <a:cs typeface="Poppins Medium"/>
+                  <a:sym typeface="Poppins Medium"/>
+                </a:rPr>
+                <a:t>{{METRIC_8_LABEL}}</a:t>
+              </a:r>
+              <a:endParaRPr b="0" i="0" sz="1400" u="none" cap="none" strike="noStrike">
+                <a:solidFill>
+                  <a:srgbClr val="000000"/>
+                </a:solidFill>
+                <a:latin typeface="Arial"/>
+                <a:ea typeface="Arial"/>
+                <a:cs typeface="Arial"/>
+                <a:sym typeface="Arial"/>
+              </a:endParaRPr>
+            </a:p>
+          </p:txBody>
+        </p:sp>
+        <p:sp>
+          <p:nvSpPr>
+            <p:cNvPr id="109" name="Google Shape;85;p5"/>
+            <p:cNvSpPr txBox="1"/>
+            <p:nvPr/>
+          </p:nvSpPr>
+          <p:spPr>
+            <a:xfrm>
+              <a:off x="1112490" y="1593124"/>
+              <a:ext cx="1485300" cy="324000"/>
+            </a:xfrm>
+            <a:prstGeom prst="rect">
+              <a:avLst/>
+            </a:prstGeom>
+            <a:noFill/>
+            <a:ln>
+              <a:noFill/>
+            </a:ln>
+          </p:spPr>
+          <p:txBody>
+            <a:bodyPr anchorCtr="0" anchor="t" bIns="45700" lIns="0" spcFirstLastPara="1" rIns="91425" wrap="square" tIns="45700">
+              <a:spAutoFit/>
+            </a:bodyPr>
+            <a:lstStyle/>
+            <a:p>
+              <a:pPr indent="0" lvl="0" marL="0" marR="0" rtl="0" algn="l">
+                <a:lnSpc>
+                  <a:spcPct val="100000"/>
+                </a:lnSpc>
+                <a:spcBef>
+                  <a:spcPts val="0"/>
+                </a:spcBef>
+                <a:spcAft>
+                  <a:spcPts val="0"/>
+                </a:spcAft>
+                <a:buClr>
+                  <a:srgbClr val="000000"/>
+                </a:buClr>
+                <a:buSzPts val="2000"/>
+                <a:buFont typeface="Arial"/>
+                <a:buNone/>
+              </a:pPr>
+              <a:r>
+                <a:rPr b="1" i="0" lang="en-US" sz="2100" u="none" cap="none" strike="noStrike">
+                  <a:solidFill>
+                    <a:schemeClr val="lt1"/>
+                  </a:solidFill>
+                  <a:latin typeface="Poppins"/>
+                  <a:ea typeface="Poppins"/>
+                  <a:cs typeface="Poppins"/>
+                  <a:sym typeface="Poppins"/>
+                </a:rPr>
+                <a:t>{{METRIC_8_VALUE}}</a:t>
               </a:r>
               <a:endParaRPr b="0" i="0" sz="1400" u="none" cap="none" strike="noStrike">
                 <a:solidFill>

</xml_diff>

<commit_message>
Fix slide title font sizes to 28pt uniform, enlarge Metric Guide text
</commit_message>
<xml_diff>
--- a/templates/dark.pptx
+++ b/templates/dark.pptx
@@ -10437,7 +10437,7 @@
               <a:buNone/>
             </a:pPr>
             <a:r>
-              <a:rPr b="0" i="0" lang="en-US" sz="4000" u="none" cap="none" strike="noStrike">
+              <a:rPr b="0" i="0" lang="en-US" sz="2800" u="none" cap="none" strike="noStrike">
                 <a:solidFill>
                   <a:srgbClr val="FFFFFF"/>
                 </a:solidFill>
@@ -10528,7 +10528,7 @@
               <a:buNone/>
             </a:pPr>
             <a:r>
-              <a:rPr b="0" i="0" lang="en-US" sz="4000" u="none" cap="none" strike="noStrike">
+              <a:rPr b="0" i="0" lang="en-US" sz="2800" u="none" cap="none" strike="noStrike">
                 <a:solidFill>
                   <a:schemeClr val="lt1"/>
                 </a:solidFill>
@@ -10933,7 +10933,7 @@
                     <a:buNone/>
                   </a:pPr>
                   <a:r>
-                    <a:rPr b="0" i="0" lang="en-US" sz="900" u="none" cap="none" strike="noStrike">
+                    <a:rPr b="0" i="0" lang="en-US" sz="1000" u="none" cap="none" strike="noStrike">
                       <a:solidFill>
                         <a:srgbClr val="BFBFBF"/>
                       </a:solidFill>
@@ -11311,7 +11311,7 @@
                     <a:buNone/>
                   </a:pPr>
                   <a:r>
-                    <a:rPr b="0" i="0" lang="en-US" sz="900" u="none" cap="none" strike="noStrike">
+                    <a:rPr b="0" i="0" lang="en-US" sz="1000" u="none" cap="none" strike="noStrike">
                       <a:solidFill>
                         <a:srgbClr val="BFBFBF"/>
                       </a:solidFill>
@@ -11701,7 +11701,7 @@
                     <a:buNone/>
                   </a:pPr>
                   <a:r>
-                    <a:rPr b="0" i="0" lang="en-US" sz="900" u="none" cap="none" strike="noStrike">
+                    <a:rPr b="0" i="0" lang="en-US" sz="1000" u="none" cap="none" strike="noStrike">
                       <a:solidFill>
                         <a:srgbClr val="BFBFBF"/>
                       </a:solidFill>
@@ -12094,7 +12094,7 @@
                     <a:buNone/>
                   </a:pPr>
                   <a:r>
-                    <a:rPr b="0" i="0" lang="en-US" sz="900" u="none" cap="none" strike="noStrike">
+                    <a:rPr b="0" i="0" lang="en-US" sz="1000" u="none" cap="none" strike="noStrike">
                       <a:solidFill>
                         <a:srgbClr val="BFBFBF"/>
                       </a:solidFill>
@@ -12472,7 +12472,7 @@
                     <a:buNone/>
                   </a:pPr>
                   <a:r>
-                    <a:rPr b="0" i="0" lang="en-US" sz="900" u="none" cap="none" strike="noStrike">
+                    <a:rPr b="0" i="0" lang="en-US" sz="1000" u="none" cap="none" strike="noStrike">
                       <a:solidFill>
                         <a:srgbClr val="BFBFBF"/>
                       </a:solidFill>
@@ -12862,7 +12862,7 @@
                     <a:buNone/>
                   </a:pPr>
                   <a:r>
-                    <a:rPr b="0" i="0" lang="en-US" sz="900" u="none" cap="none" strike="noStrike">
+                    <a:rPr b="0" i="0" lang="en-US" sz="1000" u="none" cap="none" strike="noStrike">
                       <a:solidFill>
                         <a:srgbClr val="BFBFBF"/>
                       </a:solidFill>
@@ -13255,7 +13255,7 @@
                     <a:buNone/>
                   </a:pPr>
                   <a:r>
-                    <a:rPr b="0" i="0" lang="en-US" sz="900" u="none" cap="none" strike="noStrike">
+                    <a:rPr b="0" i="0" lang="en-US" sz="1000" u="none" cap="none" strike="noStrike">
                       <a:solidFill>
                         <a:srgbClr val="BFBFBF"/>
                       </a:solidFill>
@@ -13645,7 +13645,7 @@
                     <a:buNone/>
                   </a:pPr>
                   <a:r>
-                    <a:rPr b="0" i="0" lang="en-US" sz="900" u="none" cap="none" strike="noStrike">
+                    <a:rPr b="0" i="0" lang="en-US" sz="1000" u="none" cap="none" strike="noStrike">
                       <a:solidFill>
                         <a:srgbClr val="BFBFBF"/>
                       </a:solidFill>
@@ -14023,7 +14023,7 @@
                     <a:buNone/>
                   </a:pPr>
                   <a:r>
-                    <a:rPr b="0" i="0" lang="en-US" sz="900" u="none" cap="none" strike="noStrike">
+                    <a:rPr b="0" i="0" lang="en-US" sz="1000" u="none" cap="none" strike="noStrike">
                       <a:solidFill>
                         <a:srgbClr val="BFBFBF"/>
                       </a:solidFill>
@@ -14428,7 +14428,7 @@
                     <a:buNone/>
                   </a:pPr>
                   <a:r>
-                    <a:rPr b="0" i="0" lang="en-US" sz="900" u="none" cap="none" strike="noStrike">
+                    <a:rPr b="0" i="0" lang="en-US" sz="1000" u="none" cap="none" strike="noStrike">
                       <a:solidFill>
                         <a:srgbClr val="BFBFBF"/>
                       </a:solidFill>
@@ -14818,7 +14818,7 @@
                     <a:buNone/>
                   </a:pPr>
                   <a:r>
-                    <a:rPr b="0" i="0" lang="en-US" sz="900" u="none" cap="none" strike="noStrike">
+                    <a:rPr b="0" i="0" lang="en-US" sz="1000" u="none" cap="none" strike="noStrike">
                       <a:solidFill>
                         <a:srgbClr val="BFBFBF"/>
                       </a:solidFill>
@@ -15196,7 +15196,7 @@
                     <a:buNone/>
                   </a:pPr>
                   <a:r>
-                    <a:rPr b="0" i="0" lang="en-US" sz="900" u="none" cap="none" strike="noStrike">
+                    <a:rPr b="0" i="0" lang="en-US" sz="1000" u="none" cap="none" strike="noStrike">
                       <a:solidFill>
                         <a:srgbClr val="BFBFBF"/>
                       </a:solidFill>

</xml_diff>